<commit_message>
Widen opener line, shorten Day 1 subtitle, add README with Canva instructions
Co-Authored-By: Claude Opus 5.5 <noreply@anthropic.com>
Claude-Session: https://claude.ai/code/session_01RnMzsxqDMfgar4HrYCdSBS
</commit_message>
<xml_diff>
--- a/templates/01-day-1.pptx
+++ b/templates/01-day-1.pptx
@@ -3399,7 +3399,7 @@
         <p:spPr>
           <a:xfrm>
             <a:off x="666750" y="5143500"/>
-            <a:ext cx="2857500" cy="381000"/>
+            <a:ext cx="5715000" cy="381000"/>
           </a:xfrm>
           <a:prstGeom prst="rect">
             <a:avLst/>
@@ -3542,7 +3542,7 @@
                 </a:solidFill>
                 <a:latin typeface="Montserrat"/>
               </a:rPr>
-              <a:t>Opening Day Highlights  ·  Tuesday, 30 September</a:t>
+              <a:t>Opening Day Highlights</a:t>
             </a:r>
           </a:p>
         </p:txBody>

</xml_diff>

<commit_message>
Auto-fit big titles so long words never overflow; tidy Graduation wording
Co-Authored-By: Claude Opus 5.5 <noreply@anthropic.com>
Claude-Session: https://claude.ai/code/session_01RnMzsxqDMfgar4HrYCdSBS
</commit_message>
<xml_diff>
--- a/templates/01-day-1.pptx
+++ b/templates/01-day-1.pptx
@@ -7355,8 +7355,8 @@
         </p:nvSpPr>
         <p:spPr>
           <a:xfrm>
-            <a:off x="666750" y="4000500"/>
-            <a:ext cx="8953500" cy="3143250"/>
+            <a:off x="666750" y="2857500"/>
+            <a:ext cx="8953500" cy="4095750"/>
           </a:xfrm>
           <a:prstGeom prst="rect">
             <a:avLst/>
@@ -7375,7 +7375,7 @@
               </a:lnSpc>
             </a:pPr>
             <a:r>
-              <a:rPr sz="9000" b="1">
+              <a:rPr sz="7125" b="1">
                 <a:solidFill>
                   <a:srgbClr val="FFFFFF"/>
                 </a:solidFill>
@@ -7391,7 +7391,7 @@
               </a:lnSpc>
             </a:pPr>
             <a:r>
-              <a:rPr sz="9000" b="1">
+              <a:rPr sz="7125" b="1">
                 <a:solidFill>
                   <a:srgbClr val="FFFFFF"/>
                 </a:solidFill>
@@ -7410,7 +7410,7 @@
         </p:nvSpPr>
         <p:spPr>
           <a:xfrm>
-            <a:off x="666750" y="7239000"/>
+            <a:off x="666750" y="5206365"/>
             <a:ext cx="8953500" cy="1143000"/>
           </a:xfrm>
           <a:prstGeom prst="rect">

</xml_diff>

<commit_message>
Replace AES branding with FOA 2026 / #FOA2026 everywhere
Co-Authored-By: Claude Opus 5.5 <noreply@anthropic.com>
Claude-Session: https://claude.ai/code/session_01RnMzsxqDMfgar4HrYCdSBS
</commit_message>
<xml_diff>
--- a/templates/01-day-1.pptx
+++ b/templates/01-day-1.pptx
@@ -3266,7 +3266,7 @@
                 </a:solidFill>
                 <a:latin typeface="Montserrat"/>
               </a:rPr>
-              <a:t>AES 2026  ·  DAY 1</a:t>
+              <a:t>FOA 2026  ·  DAY 1</a:t>
             </a:r>
           </a:p>
         </p:txBody>
@@ -3556,7 +3556,7 @@
                 </a:solidFill>
                 <a:latin typeface="Montserrat"/>
               </a:rPr>
-              <a:t>AES 2026  ·  DAY 1</a:t>
+              <a:t>FOA 2026  ·  DAY 1</a:t>
             </a:r>
           </a:p>
         </p:txBody>
@@ -3841,7 +3841,7 @@
                 </a:solidFill>
                 <a:latin typeface="Montserrat"/>
               </a:rPr>
-              <a:t>AES 2026  ·  DAY 1</a:t>
+              <a:t>FOA 2026  ·  DAY 1</a:t>
             </a:r>
           </a:p>
         </p:txBody>
@@ -4012,7 +4012,7 @@
                 </a:solidFill>
                 <a:latin typeface="Montserrat"/>
               </a:rPr>
-              <a:t>AES 2026  ·  DAY 1</a:t>
+              <a:t>FOA 2026  ·  DAY 1</a:t>
             </a:r>
           </a:p>
         </p:txBody>

</xml_diff>